<commit_message>
docs: actualiza la presentación de avances (roles fusionados)
</commit_message>
<xml_diff>
--- a/docs/avances/avances-backend.pptx
+++ b/docs/avances/avances-backend.pptx
@@ -4137,7 +4137,7 @@
                   <a:srgbClr val="5B6679"/>
                 </a:solidFill>
               </a:rPr>
-              <a:t>Un único catálogo decide qué puede hacer cada rol (PR #54, en revisión).</a:t>
+              <a:t>Un único catálogo decide qué puede hacer cada rol (PR #54, fusionado).</a:t>
             </a:r>
             <a:endParaRPr lang="en-US" sz="1600" dirty="0"/>
           </a:p>
@@ -5282,7 +5282,7 @@
                   <a:srgbClr val="5B6679"/>
                 </a:solidFill>
               </a:rPr>
-              <a:t>Solo el rol más alto, y siempre por debajo de sí mismo (PR #54).</a:t>
+              <a:t>Solo el rol más alto, y siempre por debajo de sí mismo.</a:t>
             </a:r>
             <a:endParaRPr lang="en-US" sz="1600" dirty="0"/>
           </a:p>

</xml_diff>

<commit_message>
docs: dark thin style for the Pages portal and the progress deck
</commit_message>
<xml_diff>
--- a/docs/avances/avances-backend.pptx
+++ b/docs/avances/avances-backend.pptx
@@ -1836,7 +1836,7 @@
     <p:bg>
       <p:bgPr>
         <a:solidFill>
-          <a:srgbClr val="16295C"/>
+          <a:srgbClr val="000000"/>
         </a:solidFill>
       </p:bgPr>
     </p:bg>
@@ -1917,7 +1917,7 @@
             <a:r>
               <a:rPr lang="en-US" sz="2000" dirty="0">
                 <a:solidFill>
-                  <a:srgbClr val="DBE4FF"/>
+                  <a:srgbClr val="8A8A8A"/>
                 </a:solidFill>
               </a:rPr>
               <a:t>Avances de la API, la base de datos y el motor C++ · 4–8 oct 2026</a:t>
@@ -1953,7 +1953,7 @@
             <a:r>
               <a:rPr lang="en-US" sz="1400" dirty="0">
                 <a:solidFill>
-                  <a:srgbClr val="FFB4A6"/>
+                  <a:srgbClr val="39FF14"/>
                 </a:solidFill>
               </a:rPr>
               <a:t>8 de octubre de 2026</a:t>
@@ -1976,7 +1976,7 @@
     <p:bg>
       <p:bgPr>
         <a:solidFill>
-          <a:srgbClr val="FFFFFF"/>
+          <a:srgbClr val="000000"/>
         </a:solidFill>
       </p:bgPr>
     </p:bg>
@@ -2021,7 +2021,7 @@
             <a:r>
               <a:rPr lang="en-US" sz="3000" b="1" dirty="0">
                 <a:solidFill>
-                  <a:srgbClr val="1B2536"/>
+                  <a:srgbClr val="FFFFFF"/>
                 </a:solidFill>
               </a:rPr>
               <a:t>Calidad</a:t>
@@ -2057,7 +2057,7 @@
             <a:r>
               <a:rPr lang="en-US" sz="1600" dirty="0">
                 <a:solidFill>
-                  <a:srgbClr val="5B6679"/>
+                  <a:srgbClr val="8A8A8A"/>
                 </a:solidFill>
               </a:rPr>
               <a:t>Cifras de hoy.</a:t>
@@ -2083,11 +2083,11 @@
             </a:avLst>
           </a:prstGeom>
           <a:solidFill>
-            <a:srgbClr val="F1F5FB"/>
+            <a:srgbClr val="0A0A0A"/>
           </a:solidFill>
           <a:ln w="12700">
             <a:solidFill>
-              <a:srgbClr val="F1F5FB"/>
+              <a:srgbClr val="222222"/>
             </a:solidFill>
             <a:prstDash val="solid"/>
           </a:ln>
@@ -2120,7 +2120,7 @@
             <a:r>
               <a:rPr lang="en-US" sz="3600" b="1" dirty="0">
                 <a:solidFill>
-                  <a:srgbClr val="2F6FED"/>
+                  <a:srgbClr val="39FF14"/>
                 </a:solidFill>
               </a:rPr>
               <a:t>48</a:t>
@@ -2156,7 +2156,7 @@
             <a:r>
               <a:rPr lang="en-US" sz="1200" dirty="0">
                 <a:solidFill>
-                  <a:srgbClr val="5B6679"/>
+                  <a:srgbClr val="8A8A8A"/>
                 </a:solidFill>
               </a:rPr>
               <a:t>tests de la API</a:t>
@@ -2182,11 +2182,11 @@
             </a:avLst>
           </a:prstGeom>
           <a:solidFill>
-            <a:srgbClr val="F1F5FB"/>
+            <a:srgbClr val="0A0A0A"/>
           </a:solidFill>
           <a:ln w="12700">
             <a:solidFill>
-              <a:srgbClr val="F1F5FB"/>
+              <a:srgbClr val="222222"/>
             </a:solidFill>
             <a:prstDash val="solid"/>
           </a:ln>
@@ -2219,7 +2219,7 @@
             <a:r>
               <a:rPr lang="en-US" sz="3600" b="1" dirty="0">
                 <a:solidFill>
-                  <a:srgbClr val="2F6FED"/>
+                  <a:srgbClr val="39FF14"/>
                 </a:solidFill>
               </a:rPr>
               <a:t>26</a:t>
@@ -2255,7 +2255,7 @@
             <a:r>
               <a:rPr lang="en-US" sz="1200" dirty="0">
                 <a:solidFill>
-                  <a:srgbClr val="5B6679"/>
+                  <a:srgbClr val="8A8A8A"/>
                 </a:solidFill>
               </a:rPr>
               <a:t>tests de la app</a:t>
@@ -2281,11 +2281,11 @@
             </a:avLst>
           </a:prstGeom>
           <a:solidFill>
-            <a:srgbClr val="F1F5FB"/>
+            <a:srgbClr val="0A0A0A"/>
           </a:solidFill>
           <a:ln w="12700">
             <a:solidFill>
-              <a:srgbClr val="F1F5FB"/>
+              <a:srgbClr val="222222"/>
             </a:solidFill>
             <a:prstDash val="solid"/>
           </a:ln>
@@ -2318,7 +2318,7 @@
             <a:r>
               <a:rPr lang="en-US" sz="3600" b="1" dirty="0">
                 <a:solidFill>
-                  <a:srgbClr val="2F6FED"/>
+                  <a:srgbClr val="39FF14"/>
                 </a:solidFill>
               </a:rPr>
               <a:t>5</a:t>
@@ -2354,7 +2354,7 @@
             <a:r>
               <a:rPr lang="en-US" sz="1200" dirty="0">
                 <a:solidFill>
-                  <a:srgbClr val="5B6679"/>
+                  <a:srgbClr val="8A8A8A"/>
                 </a:solidFill>
               </a:rPr>
               <a:t>roles probados</a:t>
@@ -2394,7 +2394,7 @@
             <a:r>
               <a:rPr lang="en-US" sz="1600" dirty="0">
                 <a:solidFill>
-                  <a:srgbClr val="1B2536"/>
+                  <a:srgbClr val="FFFFFF"/>
                 </a:solidFill>
               </a:rPr>
               <a:t>Una regresión se detectó y corrigió antes de integrarse (PR #22)</a:t>
@@ -2412,7 +2412,7 @@
             <a:r>
               <a:rPr lang="en-US" sz="1600" dirty="0">
                 <a:solidFill>
-                  <a:srgbClr val="1B2536"/>
+                  <a:srgbClr val="FFFFFF"/>
                 </a:solidFill>
               </a:rPr>
               <a:t>Comprobación de frontera pública en cada cambio</a:t>
@@ -2430,7 +2430,7 @@
             <a:r>
               <a:rPr lang="en-US" sz="1600" dirty="0">
                 <a:solidFill>
-                  <a:srgbClr val="1B2536"/>
+                  <a:srgbClr val="FFFFFF"/>
                 </a:solidFill>
               </a:rPr>
               <a:t>Todo cambio entra por PR y lo fusiona solo el dueño</a:t>
@@ -2489,7 +2489,7 @@
     <p:bg>
       <p:bgPr>
         <a:solidFill>
-          <a:srgbClr val="FFFFFF"/>
+          <a:srgbClr val="000000"/>
         </a:solidFill>
       </p:bgPr>
     </p:bg>
@@ -2534,7 +2534,7 @@
             <a:r>
               <a:rPr lang="en-US" sz="3000" b="1" dirty="0">
                 <a:solidFill>
-                  <a:srgbClr val="1B2536"/>
+                  <a:srgbClr val="FFFFFF"/>
                 </a:solidFill>
               </a:rPr>
               <a:t>Pendiente y riesgos</a:t>
@@ -2570,7 +2570,7 @@
             <a:r>
               <a:rPr lang="en-US" sz="1600" dirty="0">
                 <a:solidFill>
-                  <a:srgbClr val="5B6679"/>
+                  <a:srgbClr val="8A8A8A"/>
                 </a:solidFill>
               </a:rPr>
               <a:t>Lo que falta, dicho claro.</a:t>
@@ -2610,7 +2610,7 @@
             <a:r>
               <a:rPr lang="en-US" sz="1600" dirty="0">
                 <a:solidFill>
-                  <a:srgbClr val="1B2536"/>
+                  <a:srgbClr val="FFFFFF"/>
                 </a:solidFill>
               </a:rPr>
               <a:t>Primera ejecución real en el Mac (preparada, sin probar)</a:t>
@@ -2628,7 +2628,7 @@
             <a:r>
               <a:rPr lang="en-US" sz="1600" dirty="0">
                 <a:solidFill>
-                  <a:srgbClr val="1B2536"/>
+                  <a:srgbClr val="FFFFFF"/>
                 </a:solidFill>
               </a:rPr>
               <a:t>Rotar la contraseña de pruebas de Neon</a:t>
@@ -2646,7 +2646,7 @@
             <a:r>
               <a:rPr lang="en-US" sz="1600" dirty="0">
                 <a:solidFill>
-                  <a:srgbClr val="1B2536"/>
+                  <a:srgbClr val="FFFFFF"/>
                 </a:solidFill>
               </a:rPr>
               <a:t>Interfaz de usuario y de sudev sobre el contrato de /me</a:t>
@@ -2664,7 +2664,7 @@
             <a:r>
               <a:rPr lang="en-US" sz="1600" dirty="0">
                 <a:solidFill>
-                  <a:srgbClr val="1B2536"/>
+                  <a:srgbClr val="FFFFFF"/>
                 </a:solidFill>
               </a:rPr>
               <a:t>Interpretación de resultados: no existe, por decisión</a:t>
@@ -2723,7 +2723,7 @@
     <p:bg>
       <p:bgPr>
         <a:solidFill>
-          <a:srgbClr val="FFFFFF"/>
+          <a:srgbClr val="000000"/>
         </a:solidFill>
       </p:bgPr>
     </p:bg>
@@ -2768,7 +2768,7 @@
             <a:r>
               <a:rPr lang="en-US" sz="3000" b="1" dirty="0">
                 <a:solidFill>
-                  <a:srgbClr val="1B2536"/>
+                  <a:srgbClr val="FFFFFF"/>
                 </a:solidFill>
               </a:rPr>
               <a:t>Mapa de repositorios</a:t>
@@ -2804,7 +2804,7 @@
             <a:r>
               <a:rPr lang="en-US" sz="1600" dirty="0">
                 <a:solidFill>
-                  <a:srgbClr val="5B6679"/>
+                  <a:srgbClr val="8A8A8A"/>
                 </a:solidFill>
               </a:rPr>
               <a:t>Todo en github.com/NeoRetroo38.</a:t>
@@ -2851,7 +2851,7 @@
                       <a:r>
                         <a:rPr lang="en-US" sz="1400" b="1" dirty="0">
                           <a:solidFill>
-                            <a:srgbClr val="5B6679"/>
+                            <a:srgbClr val="8A8A8A"/>
                           </a:solidFill>
                         </a:rPr>
                         <a:t>Repositorio</a:t>
@@ -2862,7 +2862,7 @@
                   <a:tcPr marL="91440" marR="91440" marT="45720" marB="45720">
                     <a:lnL w="12700" cap="flat" cmpd="sng" algn="ctr">
                       <a:solidFill>
-                        <a:srgbClr val="E3E8F1"/>
+                        <a:srgbClr val="222222"/>
                       </a:solidFill>
                       <a:prstDash val="solid"/>
                       <a:round/>
@@ -2871,7 +2871,7 @@
                     </a:lnL>
                     <a:lnR w="12700" cap="flat" cmpd="sng" algn="ctr">
                       <a:solidFill>
-                        <a:srgbClr val="E3E8F1"/>
+                        <a:srgbClr val="222222"/>
                       </a:solidFill>
                       <a:prstDash val="solid"/>
                       <a:round/>
@@ -2880,7 +2880,7 @@
                     </a:lnR>
                     <a:lnT w="12700" cap="flat" cmpd="sng" algn="ctr">
                       <a:solidFill>
-                        <a:srgbClr val="E3E8F1"/>
+                        <a:srgbClr val="222222"/>
                       </a:solidFill>
                       <a:prstDash val="solid"/>
                       <a:round/>
@@ -2889,7 +2889,7 @@
                     </a:lnT>
                     <a:lnB w="12700" cap="flat" cmpd="sng" algn="ctr">
                       <a:solidFill>
-                        <a:srgbClr val="E3E8F1"/>
+                        <a:srgbClr val="222222"/>
                       </a:solidFill>
                       <a:prstDash val="solid"/>
                       <a:round/>
@@ -2909,7 +2909,7 @@
                       <a:r>
                         <a:rPr lang="en-US" sz="1400" b="1" dirty="0">
                           <a:solidFill>
-                            <a:srgbClr val="5B6679"/>
+                            <a:srgbClr val="8A8A8A"/>
                           </a:solidFill>
                         </a:rPr>
                         <a:t>Qué es</a:t>
@@ -2920,7 +2920,7 @@
                   <a:tcPr marL="91440" marR="91440" marT="45720" marB="45720">
                     <a:lnL w="12700" cap="flat" cmpd="sng" algn="ctr">
                       <a:solidFill>
-                        <a:srgbClr val="E3E8F1"/>
+                        <a:srgbClr val="222222"/>
                       </a:solidFill>
                       <a:prstDash val="solid"/>
                       <a:round/>
@@ -2929,7 +2929,7 @@
                     </a:lnL>
                     <a:lnR w="12700" cap="flat" cmpd="sng" algn="ctr">
                       <a:solidFill>
-                        <a:srgbClr val="E3E8F1"/>
+                        <a:srgbClr val="222222"/>
                       </a:solidFill>
                       <a:prstDash val="solid"/>
                       <a:round/>
@@ -2938,7 +2938,7 @@
                     </a:lnR>
                     <a:lnT w="12700" cap="flat" cmpd="sng" algn="ctr">
                       <a:solidFill>
-                        <a:srgbClr val="E3E8F1"/>
+                        <a:srgbClr val="222222"/>
                       </a:solidFill>
                       <a:prstDash val="solid"/>
                       <a:round/>
@@ -2947,7 +2947,7 @@
                     </a:lnT>
                     <a:lnB w="12700" cap="flat" cmpd="sng" algn="ctr">
                       <a:solidFill>
-                        <a:srgbClr val="E3E8F1"/>
+                        <a:srgbClr val="222222"/>
                       </a:solidFill>
                       <a:prstDash val="solid"/>
                       <a:round/>
@@ -2969,7 +2969,7 @@
                       <a:r>
                         <a:rPr lang="en-US" sz="1400" dirty="0">
                           <a:solidFill>
-                            <a:srgbClr val="1B2536"/>
+                            <a:srgbClr val="FFFFFF"/>
                           </a:solidFill>
                         </a:rPr>
                         <a:t>choisys</a:t>
@@ -2980,7 +2980,7 @@
                   <a:tcPr marL="91440" marR="91440" marT="45720" marB="45720">
                     <a:lnL w="12700" cap="flat" cmpd="sng" algn="ctr">
                       <a:solidFill>
-                        <a:srgbClr val="E3E8F1"/>
+                        <a:srgbClr val="222222"/>
                       </a:solidFill>
                       <a:prstDash val="solid"/>
                       <a:round/>
@@ -2989,7 +2989,7 @@
                     </a:lnL>
                     <a:lnR w="12700" cap="flat" cmpd="sng" algn="ctr">
                       <a:solidFill>
-                        <a:srgbClr val="E3E8F1"/>
+                        <a:srgbClr val="222222"/>
                       </a:solidFill>
                       <a:prstDash val="solid"/>
                       <a:round/>
@@ -2998,7 +2998,7 @@
                     </a:lnR>
                     <a:lnT w="12700" cap="flat" cmpd="sng" algn="ctr">
                       <a:solidFill>
-                        <a:srgbClr val="E3E8F1"/>
+                        <a:srgbClr val="222222"/>
                       </a:solidFill>
                       <a:prstDash val="solid"/>
                       <a:round/>
@@ -3007,7 +3007,7 @@
                     </a:lnT>
                     <a:lnB w="12700" cap="flat" cmpd="sng" algn="ctr">
                       <a:solidFill>
-                        <a:srgbClr val="E3E8F1"/>
+                        <a:srgbClr val="222222"/>
                       </a:solidFill>
                       <a:prstDash val="solid"/>
                       <a:round/>
@@ -3027,7 +3027,7 @@
                       <a:r>
                         <a:rPr lang="en-US" sz="1400" dirty="0">
                           <a:solidFill>
-                            <a:srgbClr val="1B2536"/>
+                            <a:srgbClr val="FFFFFF"/>
                           </a:solidFill>
                         </a:rPr>
                         <a:t>Producto: app, API, base de datos (TypeScript)</a:t>
@@ -3038,7 +3038,7 @@
                   <a:tcPr marL="91440" marR="91440" marT="45720" marB="45720">
                     <a:lnL w="12700" cap="flat" cmpd="sng" algn="ctr">
                       <a:solidFill>
-                        <a:srgbClr val="E3E8F1"/>
+                        <a:srgbClr val="222222"/>
                       </a:solidFill>
                       <a:prstDash val="solid"/>
                       <a:round/>
@@ -3047,7 +3047,7 @@
                     </a:lnL>
                     <a:lnR w="12700" cap="flat" cmpd="sng" algn="ctr">
                       <a:solidFill>
-                        <a:srgbClr val="E3E8F1"/>
+                        <a:srgbClr val="222222"/>
                       </a:solidFill>
                       <a:prstDash val="solid"/>
                       <a:round/>
@@ -3056,7 +3056,7 @@
                     </a:lnR>
                     <a:lnT w="12700" cap="flat" cmpd="sng" algn="ctr">
                       <a:solidFill>
-                        <a:srgbClr val="E3E8F1"/>
+                        <a:srgbClr val="222222"/>
                       </a:solidFill>
                       <a:prstDash val="solid"/>
                       <a:round/>
@@ -3065,7 +3065,7 @@
                     </a:lnT>
                     <a:lnB w="12700" cap="flat" cmpd="sng" algn="ctr">
                       <a:solidFill>
-                        <a:srgbClr val="E3E8F1"/>
+                        <a:srgbClr val="222222"/>
                       </a:solidFill>
                       <a:prstDash val="solid"/>
                       <a:round/>
@@ -3087,7 +3087,7 @@
                       <a:r>
                         <a:rPr lang="en-US" sz="1400" dirty="0">
                           <a:solidFill>
-                            <a:srgbClr val="1B2536"/>
+                            <a:srgbClr val="FFFFFF"/>
                           </a:solidFill>
                         </a:rPr>
                         <a:t>neos-cube</a:t>
@@ -3098,7 +3098,7 @@
                   <a:tcPr marL="91440" marR="91440" marT="45720" marB="45720">
                     <a:lnL w="12700" cap="flat" cmpd="sng" algn="ctr">
                       <a:solidFill>
-                        <a:srgbClr val="E3E8F1"/>
+                        <a:srgbClr val="222222"/>
                       </a:solidFill>
                       <a:prstDash val="solid"/>
                       <a:round/>
@@ -3107,7 +3107,7 @@
                     </a:lnL>
                     <a:lnR w="12700" cap="flat" cmpd="sng" algn="ctr">
                       <a:solidFill>
-                        <a:srgbClr val="E3E8F1"/>
+                        <a:srgbClr val="222222"/>
                       </a:solidFill>
                       <a:prstDash val="solid"/>
                       <a:round/>
@@ -3116,7 +3116,7 @@
                     </a:lnR>
                     <a:lnT w="12700" cap="flat" cmpd="sng" algn="ctr">
                       <a:solidFill>
-                        <a:srgbClr val="E3E8F1"/>
+                        <a:srgbClr val="222222"/>
                       </a:solidFill>
                       <a:prstDash val="solid"/>
                       <a:round/>
@@ -3125,7 +3125,7 @@
                     </a:lnT>
                     <a:lnB w="12700" cap="flat" cmpd="sng" algn="ctr">
                       <a:solidFill>
-                        <a:srgbClr val="E3E8F1"/>
+                        <a:srgbClr val="222222"/>
                       </a:solidFill>
                       <a:prstDash val="solid"/>
                       <a:round/>
@@ -3145,7 +3145,7 @@
                       <a:r>
                         <a:rPr lang="en-US" sz="1400" dirty="0">
                           <a:solidFill>
-                            <a:srgbClr val="1B2536"/>
+                            <a:srgbClr val="FFFFFF"/>
                           </a:solidFill>
                         </a:rPr>
                         <a:t>Motor del Cubo (C++)</a:t>
@@ -3156,7 +3156,7 @@
                   <a:tcPr marL="91440" marR="91440" marT="45720" marB="45720">
                     <a:lnL w="12700" cap="flat" cmpd="sng" algn="ctr">
                       <a:solidFill>
-                        <a:srgbClr val="E3E8F1"/>
+                        <a:srgbClr val="222222"/>
                       </a:solidFill>
                       <a:prstDash val="solid"/>
                       <a:round/>
@@ -3165,7 +3165,7 @@
                     </a:lnL>
                     <a:lnR w="12700" cap="flat" cmpd="sng" algn="ctr">
                       <a:solidFill>
-                        <a:srgbClr val="E3E8F1"/>
+                        <a:srgbClr val="222222"/>
                       </a:solidFill>
                       <a:prstDash val="solid"/>
                       <a:round/>
@@ -3174,7 +3174,7 @@
                     </a:lnR>
                     <a:lnT w="12700" cap="flat" cmpd="sng" algn="ctr">
                       <a:solidFill>
-                        <a:srgbClr val="E3E8F1"/>
+                        <a:srgbClr val="222222"/>
                       </a:solidFill>
                       <a:prstDash val="solid"/>
                       <a:round/>
@@ -3183,7 +3183,7 @@
                     </a:lnT>
                     <a:lnB w="12700" cap="flat" cmpd="sng" algn="ctr">
                       <a:solidFill>
-                        <a:srgbClr val="E3E8F1"/>
+                        <a:srgbClr val="222222"/>
                       </a:solidFill>
                       <a:prstDash val="solid"/>
                       <a:round/>
@@ -3205,7 +3205,7 @@
                       <a:r>
                         <a:rPr lang="en-US" sz="1400" dirty="0">
                           <a:solidFill>
-                            <a:srgbClr val="1B2536"/>
+                            <a:srgbClr val="FFFFFF"/>
                           </a:solidFill>
                         </a:rPr>
                         <a:t>neo-cube-web</a:t>
@@ -3216,7 +3216,7 @@
                   <a:tcPr marL="91440" marR="91440" marT="45720" marB="45720">
                     <a:lnL w="12700" cap="flat" cmpd="sng" algn="ctr">
                       <a:solidFill>
-                        <a:srgbClr val="E3E8F1"/>
+                        <a:srgbClr val="222222"/>
                       </a:solidFill>
                       <a:prstDash val="solid"/>
                       <a:round/>
@@ -3225,7 +3225,7 @@
                     </a:lnL>
                     <a:lnR w="12700" cap="flat" cmpd="sng" algn="ctr">
                       <a:solidFill>
-                        <a:srgbClr val="E3E8F1"/>
+                        <a:srgbClr val="222222"/>
                       </a:solidFill>
                       <a:prstDash val="solid"/>
                       <a:round/>
@@ -3234,7 +3234,7 @@
                     </a:lnR>
                     <a:lnT w="12700" cap="flat" cmpd="sng" algn="ctr">
                       <a:solidFill>
-                        <a:srgbClr val="E3E8F1"/>
+                        <a:srgbClr val="222222"/>
                       </a:solidFill>
                       <a:prstDash val="solid"/>
                       <a:round/>
@@ -3243,7 +3243,7 @@
                     </a:lnT>
                     <a:lnB w="12700" cap="flat" cmpd="sng" algn="ctr">
                       <a:solidFill>
-                        <a:srgbClr val="E3E8F1"/>
+                        <a:srgbClr val="222222"/>
                       </a:solidFill>
                       <a:prstDash val="solid"/>
                       <a:round/>
@@ -3263,7 +3263,7 @@
                       <a:r>
                         <a:rPr lang="en-US" sz="1400" dirty="0">
                           <a:solidFill>
-                            <a:srgbClr val="1B2536"/>
+                            <a:srgbClr val="FFFFFF"/>
                           </a:solidFill>
                         </a:rPr>
                         <a:t>Utilidades públicas de dibujo (TypeScript)</a:t>
@@ -3274,7 +3274,7 @@
                   <a:tcPr marL="91440" marR="91440" marT="45720" marB="45720">
                     <a:lnL w="12700" cap="flat" cmpd="sng" algn="ctr">
                       <a:solidFill>
-                        <a:srgbClr val="E3E8F1"/>
+                        <a:srgbClr val="222222"/>
                       </a:solidFill>
                       <a:prstDash val="solid"/>
                       <a:round/>
@@ -3283,7 +3283,7 @@
                     </a:lnL>
                     <a:lnR w="12700" cap="flat" cmpd="sng" algn="ctr">
                       <a:solidFill>
-                        <a:srgbClr val="E3E8F1"/>
+                        <a:srgbClr val="222222"/>
                       </a:solidFill>
                       <a:prstDash val="solid"/>
                       <a:round/>
@@ -3292,7 +3292,7 @@
                     </a:lnR>
                     <a:lnT w="12700" cap="flat" cmpd="sng" algn="ctr">
                       <a:solidFill>
-                        <a:srgbClr val="E3E8F1"/>
+                        <a:srgbClr val="222222"/>
                       </a:solidFill>
                       <a:prstDash val="solid"/>
                       <a:round/>
@@ -3301,7 +3301,7 @@
                     </a:lnT>
                     <a:lnB w="12700" cap="flat" cmpd="sng" algn="ctr">
                       <a:solidFill>
-                        <a:srgbClr val="E3E8F1"/>
+                        <a:srgbClr val="222222"/>
                       </a:solidFill>
                       <a:prstDash val="solid"/>
                       <a:round/>
@@ -3323,7 +3323,7 @@
                       <a:r>
                         <a:rPr lang="en-US" sz="1400" dirty="0">
                           <a:solidFill>
-                            <a:srgbClr val="1B2536"/>
+                            <a:srgbClr val="FFFFFF"/>
                           </a:solidFill>
                         </a:rPr>
                         <a:t>scenarys</a:t>
@@ -3334,7 +3334,7 @@
                   <a:tcPr marL="91440" marR="91440" marT="45720" marB="45720">
                     <a:lnL w="12700" cap="flat" cmpd="sng" algn="ctr">
                       <a:solidFill>
-                        <a:srgbClr val="E3E8F1"/>
+                        <a:srgbClr val="222222"/>
                       </a:solidFill>
                       <a:prstDash val="solid"/>
                       <a:round/>
@@ -3343,7 +3343,7 @@
                     </a:lnL>
                     <a:lnR w="12700" cap="flat" cmpd="sng" algn="ctr">
                       <a:solidFill>
-                        <a:srgbClr val="E3E8F1"/>
+                        <a:srgbClr val="222222"/>
                       </a:solidFill>
                       <a:prstDash val="solid"/>
                       <a:round/>
@@ -3352,7 +3352,7 @@
                     </a:lnR>
                     <a:lnT w="12700" cap="flat" cmpd="sng" algn="ctr">
                       <a:solidFill>
-                        <a:srgbClr val="E3E8F1"/>
+                        <a:srgbClr val="222222"/>
                       </a:solidFill>
                       <a:prstDash val="solid"/>
                       <a:round/>
@@ -3361,7 +3361,7 @@
                     </a:lnT>
                     <a:lnB w="12700" cap="flat" cmpd="sng" algn="ctr">
                       <a:solidFill>
-                        <a:srgbClr val="E3E8F1"/>
+                        <a:srgbClr val="222222"/>
                       </a:solidFill>
                       <a:prstDash val="solid"/>
                       <a:round/>
@@ -3381,7 +3381,7 @@
                       <a:r>
                         <a:rPr lang="en-US" sz="1400" dirty="0">
                           <a:solidFill>
-                            <a:srgbClr val="1B2536"/>
+                            <a:srgbClr val="FFFFFF"/>
                           </a:solidFill>
                         </a:rPr>
                         <a:t>Web corporativa (privado)</a:t>
@@ -3392,7 +3392,7 @@
                   <a:tcPr marL="91440" marR="91440" marT="45720" marB="45720">
                     <a:lnL w="12700" cap="flat" cmpd="sng" algn="ctr">
                       <a:solidFill>
-                        <a:srgbClr val="E3E8F1"/>
+                        <a:srgbClr val="222222"/>
                       </a:solidFill>
                       <a:prstDash val="solid"/>
                       <a:round/>
@@ -3401,7 +3401,7 @@
                     </a:lnL>
                     <a:lnR w="12700" cap="flat" cmpd="sng" algn="ctr">
                       <a:solidFill>
-                        <a:srgbClr val="E3E8F1"/>
+                        <a:srgbClr val="222222"/>
                       </a:solidFill>
                       <a:prstDash val="solid"/>
                       <a:round/>
@@ -3410,7 +3410,7 @@
                     </a:lnR>
                     <a:lnT w="12700" cap="flat" cmpd="sng" algn="ctr">
                       <a:solidFill>
-                        <a:srgbClr val="E3E8F1"/>
+                        <a:srgbClr val="222222"/>
                       </a:solidFill>
                       <a:prstDash val="solid"/>
                       <a:round/>
@@ -3419,7 +3419,7 @@
                     </a:lnT>
                     <a:lnB w="12700" cap="flat" cmpd="sng" algn="ctr">
                       <a:solidFill>
-                        <a:srgbClr val="E3E8F1"/>
+                        <a:srgbClr val="222222"/>
                       </a:solidFill>
                       <a:prstDash val="solid"/>
                       <a:round/>
@@ -3483,7 +3483,7 @@
     <p:bg>
       <p:bgPr>
         <a:solidFill>
-          <a:srgbClr val="FFFFFF"/>
+          <a:srgbClr val="000000"/>
         </a:solidFill>
       </p:bgPr>
     </p:bg>
@@ -3528,7 +3528,7 @@
             <a:r>
               <a:rPr lang="en-US" sz="3000" b="1" dirty="0">
                 <a:solidFill>
-                  <a:srgbClr val="1B2536"/>
+                  <a:srgbClr val="FFFFFF"/>
                 </a:solidFill>
               </a:rPr>
               <a:t>Cómo encaja todo</a:t>
@@ -3564,7 +3564,7 @@
             <a:r>
               <a:rPr lang="en-US" sz="1600" dirty="0">
                 <a:solidFill>
-                  <a:srgbClr val="5B6679"/>
+                  <a:srgbClr val="8A8A8A"/>
                 </a:solidFill>
               </a:rPr>
               <a:t>Cada capa hace una sola cosa. La interfaz nunca decide seguridad.</a:t>
@@ -3590,7 +3590,7 @@
             </a:avLst>
           </a:prstGeom>
           <a:solidFill>
-            <a:srgbClr val="2F6FED"/>
+            <a:srgbClr val="111111"/>
           </a:solidFill>
           <a:ln/>
         </p:spPr>
@@ -3630,7 +3630,7 @@
             </a:avLst>
           </a:prstGeom>
           <a:solidFill>
-            <a:srgbClr val="4B5D7A"/>
+            <a:srgbClr val="111111"/>
           </a:solidFill>
           <a:ln/>
         </p:spPr>
@@ -3670,7 +3670,7 @@
             </a:avLst>
           </a:prstGeom>
           <a:solidFill>
-            <a:srgbClr val="E0533D"/>
+            <a:srgbClr val="111111"/>
           </a:solidFill>
           <a:ln/>
         </p:spPr>
@@ -3710,7 +3710,7 @@
             </a:avLst>
           </a:prstGeom>
           <a:solidFill>
-            <a:srgbClr val="2B9A6B"/>
+            <a:srgbClr val="0B2E0B"/>
           </a:solidFill>
           <a:ln/>
         </p:spPr>
@@ -3760,7 +3760,7 @@
             <a:r>
               <a:rPr lang="en-US" sz="1200" dirty="0">
                 <a:solidFill>
-                  <a:srgbClr val="5B6679"/>
+                  <a:srgbClr val="8A8A8A"/>
                 </a:solidFill>
               </a:rPr>
               <a:t>Las decisiones del Cubo pasan por el motor C++ (neos-cube), solo desde la API y solo en la propia máquina.</a:t>
@@ -3819,7 +3819,7 @@
     <p:bg>
       <p:bgPr>
         <a:solidFill>
-          <a:srgbClr val="FFFFFF"/>
+          <a:srgbClr val="000000"/>
         </a:solidFill>
       </p:bgPr>
     </p:bg>
@@ -3864,7 +3864,7 @@
             <a:r>
               <a:rPr lang="en-US" sz="3000" b="1" dirty="0">
                 <a:solidFill>
-                  <a:srgbClr val="1B2536"/>
+                  <a:srgbClr val="FFFFFF"/>
                 </a:solidFill>
               </a:rPr>
               <a:t>Cuentas y sesiones</a:t>
@@ -3900,7 +3900,7 @@
             <a:r>
               <a:rPr lang="en-US" sz="1600" dirty="0">
                 <a:solidFill>
-                  <a:srgbClr val="5B6679"/>
+                  <a:srgbClr val="8A8A8A"/>
                 </a:solidFill>
               </a:rPr>
               <a:t>Hecho y en producción de desarrollo.</a:t>
@@ -3940,7 +3940,7 @@
             <a:r>
               <a:rPr lang="en-US" sz="1600" dirty="0">
                 <a:solidFill>
-                  <a:srgbClr val="1B2536"/>
+                  <a:srgbClr val="FFFFFF"/>
                 </a:solidFill>
               </a:rPr>
               <a:t>Registro atómico: cuenta + perfil + sesión se crean juntos o no se crea nada</a:t>
@@ -3958,7 +3958,7 @@
             <a:r>
               <a:rPr lang="en-US" sz="1600" dirty="0">
                 <a:solidFill>
-                  <a:srgbClr val="1B2536"/>
+                  <a:srgbClr val="FFFFFF"/>
                 </a:solidFill>
               </a:rPr>
               <a:t>Contraseñas con hash; sesiones de 30 días, revocables</a:t>
@@ -3976,7 +3976,7 @@
             <a:r>
               <a:rPr lang="en-US" sz="1600" dirty="0">
                 <a:solidFill>
-                  <a:srgbClr val="1B2536"/>
+                  <a:srgbClr val="FFFFFF"/>
                 </a:solidFill>
               </a:rPr>
               <a:t>Límites de intentos por IP y por correo</a:t>
@@ -3994,7 +3994,7 @@
             <a:r>
               <a:rPr lang="en-US" sz="1600" dirty="0">
                 <a:solidFill>
-                  <a:srgbClr val="1B2536"/>
+                  <a:srgbClr val="FFFFFF"/>
                 </a:solidFill>
               </a:rPr>
               <a:t>Cuenta desactivada = sin acceso en la siguiente petición</a:t>
@@ -4053,7 +4053,7 @@
     <p:bg>
       <p:bgPr>
         <a:solidFill>
-          <a:srgbClr val="FFFFFF"/>
+          <a:srgbClr val="000000"/>
         </a:solidFill>
       </p:bgPr>
     </p:bg>
@@ -4098,7 +4098,7 @@
             <a:r>
               <a:rPr lang="en-US" sz="3000" b="1" dirty="0">
                 <a:solidFill>
-                  <a:srgbClr val="1B2536"/>
+                  <a:srgbClr val="FFFFFF"/>
                 </a:solidFill>
               </a:rPr>
               <a:t>Roles y capacidades</a:t>
@@ -4134,7 +4134,7 @@
             <a:r>
               <a:rPr lang="en-US" sz="1600" dirty="0">
                 <a:solidFill>
-                  <a:srgbClr val="5B6679"/>
+                  <a:srgbClr val="8A8A8A"/>
                 </a:solidFill>
               </a:rPr>
               <a:t>Un único catálogo decide qué puede hacer cada rol (PR #54, fusionado).</a:t>
@@ -4182,7 +4182,7 @@
                       <a:r>
                         <a:rPr lang="en-US" sz="1400" b="1" dirty="0">
                           <a:solidFill>
-                            <a:srgbClr val="5B6679"/>
+                            <a:srgbClr val="8A8A8A"/>
                           </a:solidFill>
                         </a:rPr>
                         <a:t>Rol interno</a:t>
@@ -4193,7 +4193,7 @@
                   <a:tcPr marL="91440" marR="91440" marT="45720" marB="45720">
                     <a:lnL w="12700" cap="flat" cmpd="sng" algn="ctr">
                       <a:solidFill>
-                        <a:srgbClr val="E3E8F1"/>
+                        <a:srgbClr val="222222"/>
                       </a:solidFill>
                       <a:prstDash val="solid"/>
                       <a:round/>
@@ -4202,7 +4202,7 @@
                     </a:lnL>
                     <a:lnR w="12700" cap="flat" cmpd="sng" algn="ctr">
                       <a:solidFill>
-                        <a:srgbClr val="E3E8F1"/>
+                        <a:srgbClr val="222222"/>
                       </a:solidFill>
                       <a:prstDash val="solid"/>
                       <a:round/>
@@ -4211,7 +4211,7 @@
                     </a:lnR>
                     <a:lnT w="12700" cap="flat" cmpd="sng" algn="ctr">
                       <a:solidFill>
-                        <a:srgbClr val="E3E8F1"/>
+                        <a:srgbClr val="222222"/>
                       </a:solidFill>
                       <a:prstDash val="solid"/>
                       <a:round/>
@@ -4220,7 +4220,7 @@
                     </a:lnT>
                     <a:lnB w="12700" cap="flat" cmpd="sng" algn="ctr">
                       <a:solidFill>
-                        <a:srgbClr val="E3E8F1"/>
+                        <a:srgbClr val="222222"/>
                       </a:solidFill>
                       <a:prstDash val="solid"/>
                       <a:round/>
@@ -4240,7 +4240,7 @@
                       <a:r>
                         <a:rPr lang="en-US" sz="1400" b="1" dirty="0">
                           <a:solidFill>
-                            <a:srgbClr val="5B6679"/>
+                            <a:srgbClr val="8A8A8A"/>
                           </a:solidFill>
                         </a:rPr>
                         <a:t>Se muestra como</a:t>
@@ -4251,7 +4251,7 @@
                   <a:tcPr marL="91440" marR="91440" marT="45720" marB="45720">
                     <a:lnL w="12700" cap="flat" cmpd="sng" algn="ctr">
                       <a:solidFill>
-                        <a:srgbClr val="E3E8F1"/>
+                        <a:srgbClr val="222222"/>
                       </a:solidFill>
                       <a:prstDash val="solid"/>
                       <a:round/>
@@ -4260,7 +4260,7 @@
                     </a:lnL>
                     <a:lnR w="12700" cap="flat" cmpd="sng" algn="ctr">
                       <a:solidFill>
-                        <a:srgbClr val="E3E8F1"/>
+                        <a:srgbClr val="222222"/>
                       </a:solidFill>
                       <a:prstDash val="solid"/>
                       <a:round/>
@@ -4269,7 +4269,7 @@
                     </a:lnR>
                     <a:lnT w="12700" cap="flat" cmpd="sng" algn="ctr">
                       <a:solidFill>
-                        <a:srgbClr val="E3E8F1"/>
+                        <a:srgbClr val="222222"/>
                       </a:solidFill>
                       <a:prstDash val="solid"/>
                       <a:round/>
@@ -4278,7 +4278,7 @@
                     </a:lnT>
                     <a:lnB w="12700" cap="flat" cmpd="sng" algn="ctr">
                       <a:solidFill>
-                        <a:srgbClr val="E3E8F1"/>
+                        <a:srgbClr val="222222"/>
                       </a:solidFill>
                       <a:prstDash val="solid"/>
                       <a:round/>
@@ -4298,7 +4298,7 @@
                       <a:r>
                         <a:rPr lang="en-US" sz="1400" b="1" dirty="0">
                           <a:solidFill>
-                            <a:srgbClr val="5B6679"/>
+                            <a:srgbClr val="8A8A8A"/>
                           </a:solidFill>
                         </a:rPr>
                         <a:t>Capacidades</a:t>
@@ -4309,7 +4309,7 @@
                   <a:tcPr marL="91440" marR="91440" marT="45720" marB="45720">
                     <a:lnL w="12700" cap="flat" cmpd="sng" algn="ctr">
                       <a:solidFill>
-                        <a:srgbClr val="E3E8F1"/>
+                        <a:srgbClr val="222222"/>
                       </a:solidFill>
                       <a:prstDash val="solid"/>
                       <a:round/>
@@ -4318,7 +4318,7 @@
                     </a:lnL>
                     <a:lnR w="12700" cap="flat" cmpd="sng" algn="ctr">
                       <a:solidFill>
-                        <a:srgbClr val="E3E8F1"/>
+                        <a:srgbClr val="222222"/>
                       </a:solidFill>
                       <a:prstDash val="solid"/>
                       <a:round/>
@@ -4327,7 +4327,7 @@
                     </a:lnR>
                     <a:lnT w="12700" cap="flat" cmpd="sng" algn="ctr">
                       <a:solidFill>
-                        <a:srgbClr val="E3E8F1"/>
+                        <a:srgbClr val="222222"/>
                       </a:solidFill>
                       <a:prstDash val="solid"/>
                       <a:round/>
@@ -4336,7 +4336,7 @@
                     </a:lnT>
                     <a:lnB w="12700" cap="flat" cmpd="sng" algn="ctr">
                       <a:solidFill>
-                        <a:srgbClr val="E3E8F1"/>
+                        <a:srgbClr val="222222"/>
                       </a:solidFill>
                       <a:prstDash val="solid"/>
                       <a:round/>
@@ -4358,7 +4358,7 @@
                       <a:r>
                         <a:rPr lang="en-US" sz="1400" dirty="0">
                           <a:solidFill>
-                            <a:srgbClr val="1B2536"/>
+                            <a:srgbClr val="FFFFFF"/>
                           </a:solidFill>
                         </a:rPr>
                         <a:t>USER</a:t>
@@ -4369,7 +4369,7 @@
                   <a:tcPr marL="91440" marR="91440" marT="45720" marB="45720">
                     <a:lnL w="12700" cap="flat" cmpd="sng" algn="ctr">
                       <a:solidFill>
-                        <a:srgbClr val="E3E8F1"/>
+                        <a:srgbClr val="222222"/>
                       </a:solidFill>
                       <a:prstDash val="solid"/>
                       <a:round/>
@@ -4378,7 +4378,7 @@
                     </a:lnL>
                     <a:lnR w="12700" cap="flat" cmpd="sng" algn="ctr">
                       <a:solidFill>
-                        <a:srgbClr val="E3E8F1"/>
+                        <a:srgbClr val="222222"/>
                       </a:solidFill>
                       <a:prstDash val="solid"/>
                       <a:round/>
@@ -4387,7 +4387,7 @@
                     </a:lnR>
                     <a:lnT w="12700" cap="flat" cmpd="sng" algn="ctr">
                       <a:solidFill>
-                        <a:srgbClr val="E3E8F1"/>
+                        <a:srgbClr val="222222"/>
                       </a:solidFill>
                       <a:prstDash val="solid"/>
                       <a:round/>
@@ -4396,7 +4396,7 @@
                     </a:lnT>
                     <a:lnB w="12700" cap="flat" cmpd="sng" algn="ctr">
                       <a:solidFill>
-                        <a:srgbClr val="E3E8F1"/>
+                        <a:srgbClr val="222222"/>
                       </a:solidFill>
                       <a:prstDash val="solid"/>
                       <a:round/>
@@ -4416,7 +4416,7 @@
                       <a:r>
                         <a:rPr lang="en-US" sz="1400" dirty="0">
                           <a:solidFill>
-                            <a:srgbClr val="1B2536"/>
+                            <a:srgbClr val="FFFFFF"/>
                           </a:solidFill>
                         </a:rPr>
                         <a:t>usuario</a:t>
@@ -4427,7 +4427,7 @@
                   <a:tcPr marL="91440" marR="91440" marT="45720" marB="45720">
                     <a:lnL w="12700" cap="flat" cmpd="sng" algn="ctr">
                       <a:solidFill>
-                        <a:srgbClr val="E3E8F1"/>
+                        <a:srgbClr val="222222"/>
                       </a:solidFill>
                       <a:prstDash val="solid"/>
                       <a:round/>
@@ -4436,7 +4436,7 @@
                     </a:lnL>
                     <a:lnR w="12700" cap="flat" cmpd="sng" algn="ctr">
                       <a:solidFill>
-                        <a:srgbClr val="E3E8F1"/>
+                        <a:srgbClr val="222222"/>
                       </a:solidFill>
                       <a:prstDash val="solid"/>
                       <a:round/>
@@ -4445,7 +4445,7 @@
                     </a:lnR>
                     <a:lnT w="12700" cap="flat" cmpd="sng" algn="ctr">
                       <a:solidFill>
-                        <a:srgbClr val="E3E8F1"/>
+                        <a:srgbClr val="222222"/>
                       </a:solidFill>
                       <a:prstDash val="solid"/>
                       <a:round/>
@@ -4454,7 +4454,7 @@
                     </a:lnT>
                     <a:lnB w="12700" cap="flat" cmpd="sng" algn="ctr">
                       <a:solidFill>
-                        <a:srgbClr val="E3E8F1"/>
+                        <a:srgbClr val="222222"/>
                       </a:solidFill>
                       <a:prstDash val="solid"/>
                       <a:round/>
@@ -4474,7 +4474,7 @@
                       <a:r>
                         <a:rPr lang="en-US" sz="1400" dirty="0">
                           <a:solidFill>
-                            <a:srgbClr val="1B2536"/>
+                            <a:srgbClr val="FFFFFF"/>
                           </a:solidFill>
                         </a:rPr>
                         <a:t>lo propio</a:t>
@@ -4485,7 +4485,7 @@
                   <a:tcPr marL="91440" marR="91440" marT="45720" marB="45720">
                     <a:lnL w="12700" cap="flat" cmpd="sng" algn="ctr">
                       <a:solidFill>
-                        <a:srgbClr val="E3E8F1"/>
+                        <a:srgbClr val="222222"/>
                       </a:solidFill>
                       <a:prstDash val="solid"/>
                       <a:round/>
@@ -4494,7 +4494,7 @@
                     </a:lnL>
                     <a:lnR w="12700" cap="flat" cmpd="sng" algn="ctr">
                       <a:solidFill>
-                        <a:srgbClr val="E3E8F1"/>
+                        <a:srgbClr val="222222"/>
                       </a:solidFill>
                       <a:prstDash val="solid"/>
                       <a:round/>
@@ -4503,7 +4503,7 @@
                     </a:lnR>
                     <a:lnT w="12700" cap="flat" cmpd="sng" algn="ctr">
                       <a:solidFill>
-                        <a:srgbClr val="E3E8F1"/>
+                        <a:srgbClr val="222222"/>
                       </a:solidFill>
                       <a:prstDash val="solid"/>
                       <a:round/>
@@ -4512,7 +4512,7 @@
                     </a:lnT>
                     <a:lnB w="12700" cap="flat" cmpd="sng" algn="ctr">
                       <a:solidFill>
-                        <a:srgbClr val="E3E8F1"/>
+                        <a:srgbClr val="222222"/>
                       </a:solidFill>
                       <a:prstDash val="solid"/>
                       <a:round/>
@@ -4534,7 +4534,7 @@
                       <a:r>
                         <a:rPr lang="en-US" sz="1400" dirty="0">
                           <a:solidFill>
-                            <a:srgbClr val="1B2536"/>
+                            <a:srgbClr val="FFFFFF"/>
                           </a:solidFill>
                         </a:rPr>
                         <a:t>ADMIN · DEV · SUPERADMIN</a:t>
@@ -4545,7 +4545,7 @@
                   <a:tcPr marL="91440" marR="91440" marT="45720" marB="45720">
                     <a:lnL w="12700" cap="flat" cmpd="sng" algn="ctr">
                       <a:solidFill>
-                        <a:srgbClr val="E3E8F1"/>
+                        <a:srgbClr val="222222"/>
                       </a:solidFill>
                       <a:prstDash val="solid"/>
                       <a:round/>
@@ -4554,7 +4554,7 @@
                     </a:lnL>
                     <a:lnR w="12700" cap="flat" cmpd="sng" algn="ctr">
                       <a:solidFill>
-                        <a:srgbClr val="E3E8F1"/>
+                        <a:srgbClr val="222222"/>
                       </a:solidFill>
                       <a:prstDash val="solid"/>
                       <a:round/>
@@ -4563,7 +4563,7 @@
                     </a:lnR>
                     <a:lnT w="12700" cap="flat" cmpd="sng" algn="ctr">
                       <a:solidFill>
-                        <a:srgbClr val="E3E8F1"/>
+                        <a:srgbClr val="222222"/>
                       </a:solidFill>
                       <a:prstDash val="solid"/>
                       <a:round/>
@@ -4572,7 +4572,7 @@
                     </a:lnT>
                     <a:lnB w="12700" cap="flat" cmpd="sng" algn="ctr">
                       <a:solidFill>
-                        <a:srgbClr val="E3E8F1"/>
+                        <a:srgbClr val="222222"/>
                       </a:solidFill>
                       <a:prstDash val="solid"/>
                       <a:round/>
@@ -4592,7 +4592,7 @@
                       <a:r>
                         <a:rPr lang="en-US" sz="1400" dirty="0">
                           <a:solidFill>
-                            <a:srgbClr val="1B2536"/>
+                            <a:srgbClr val="FFFFFF"/>
                           </a:solidFill>
                         </a:rPr>
                         <a:t>reservados</a:t>
@@ -4603,7 +4603,7 @@
                   <a:tcPr marL="91440" marR="91440" marT="45720" marB="45720">
                     <a:lnL w="12700" cap="flat" cmpd="sng" algn="ctr">
                       <a:solidFill>
-                        <a:srgbClr val="E3E8F1"/>
+                        <a:srgbClr val="222222"/>
                       </a:solidFill>
                       <a:prstDash val="solid"/>
                       <a:round/>
@@ -4612,7 +4612,7 @@
                     </a:lnL>
                     <a:lnR w="12700" cap="flat" cmpd="sng" algn="ctr">
                       <a:solidFill>
-                        <a:srgbClr val="E3E8F1"/>
+                        <a:srgbClr val="222222"/>
                       </a:solidFill>
                       <a:prstDash val="solid"/>
                       <a:round/>
@@ -4621,7 +4621,7 @@
                     </a:lnR>
                     <a:lnT w="12700" cap="flat" cmpd="sng" algn="ctr">
                       <a:solidFill>
-                        <a:srgbClr val="E3E8F1"/>
+                        <a:srgbClr val="222222"/>
                       </a:solidFill>
                       <a:prstDash val="solid"/>
                       <a:round/>
@@ -4630,7 +4630,7 @@
                     </a:lnT>
                     <a:lnB w="12700" cap="flat" cmpd="sng" algn="ctr">
                       <a:solidFill>
-                        <a:srgbClr val="E3E8F1"/>
+                        <a:srgbClr val="222222"/>
                       </a:solidFill>
                       <a:prstDash val="solid"/>
                       <a:round/>
@@ -4650,7 +4650,7 @@
                       <a:r>
                         <a:rPr lang="en-US" sz="1400" dirty="0">
                           <a:solidFill>
-                            <a:srgbClr val="1B2536"/>
+                            <a:srgbClr val="FFFFFF"/>
                           </a:solidFill>
                         </a:rPr>
                         <a:t>= USER</a:t>
@@ -4661,7 +4661,7 @@
                   <a:tcPr marL="91440" marR="91440" marT="45720" marB="45720">
                     <a:lnL w="12700" cap="flat" cmpd="sng" algn="ctr">
                       <a:solidFill>
-                        <a:srgbClr val="E3E8F1"/>
+                        <a:srgbClr val="222222"/>
                       </a:solidFill>
                       <a:prstDash val="solid"/>
                       <a:round/>
@@ -4670,7 +4670,7 @@
                     </a:lnL>
                     <a:lnR w="12700" cap="flat" cmpd="sng" algn="ctr">
                       <a:solidFill>
-                        <a:srgbClr val="E3E8F1"/>
+                        <a:srgbClr val="222222"/>
                       </a:solidFill>
                       <a:prstDash val="solid"/>
                       <a:round/>
@@ -4679,7 +4679,7 @@
                     </a:lnR>
                     <a:lnT w="12700" cap="flat" cmpd="sng" algn="ctr">
                       <a:solidFill>
-                        <a:srgbClr val="E3E8F1"/>
+                        <a:srgbClr val="222222"/>
                       </a:solidFill>
                       <a:prstDash val="solid"/>
                       <a:round/>
@@ -4688,7 +4688,7 @@
                     </a:lnT>
                     <a:lnB w="12700" cap="flat" cmpd="sng" algn="ctr">
                       <a:solidFill>
-                        <a:srgbClr val="E3E8F1"/>
+                        <a:srgbClr val="222222"/>
                       </a:solidFill>
                       <a:prstDash val="solid"/>
                       <a:round/>
@@ -4710,7 +4710,7 @@
                       <a:r>
                         <a:rPr lang="en-US" sz="1400" dirty="0">
                           <a:solidFill>
-                            <a:srgbClr val="1B2536"/>
+                            <a:srgbClr val="FFFFFF"/>
                           </a:solidFill>
                         </a:rPr>
                         <a:t>SUPERDEV</a:t>
@@ -4721,7 +4721,7 @@
                   <a:tcPr marL="91440" marR="91440" marT="45720" marB="45720">
                     <a:lnL w="12700" cap="flat" cmpd="sng" algn="ctr">
                       <a:solidFill>
-                        <a:srgbClr val="E3E8F1"/>
+                        <a:srgbClr val="222222"/>
                       </a:solidFill>
                       <a:prstDash val="solid"/>
                       <a:round/>
@@ -4730,7 +4730,7 @@
                     </a:lnL>
                     <a:lnR w="12700" cap="flat" cmpd="sng" algn="ctr">
                       <a:solidFill>
-                        <a:srgbClr val="E3E8F1"/>
+                        <a:srgbClr val="222222"/>
                       </a:solidFill>
                       <a:prstDash val="solid"/>
                       <a:round/>
@@ -4739,7 +4739,7 @@
                     </a:lnR>
                     <a:lnT w="12700" cap="flat" cmpd="sng" algn="ctr">
                       <a:solidFill>
-                        <a:srgbClr val="E3E8F1"/>
+                        <a:srgbClr val="222222"/>
                       </a:solidFill>
                       <a:prstDash val="solid"/>
                       <a:round/>
@@ -4748,7 +4748,7 @@
                     </a:lnT>
                     <a:lnB w="12700" cap="flat" cmpd="sng" algn="ctr">
                       <a:solidFill>
-                        <a:srgbClr val="E3E8F1"/>
+                        <a:srgbClr val="222222"/>
                       </a:solidFill>
                       <a:prstDash val="solid"/>
                       <a:round/>
@@ -4768,7 +4768,7 @@
                       <a:r>
                         <a:rPr lang="en-US" sz="1400" dirty="0">
                           <a:solidFill>
-                            <a:srgbClr val="1B2536"/>
+                            <a:srgbClr val="FFFFFF"/>
                           </a:solidFill>
                         </a:rPr>
                         <a:t>sudev</a:t>
@@ -4779,7 +4779,7 @@
                   <a:tcPr marL="91440" marR="91440" marT="45720" marB="45720">
                     <a:lnL w="12700" cap="flat" cmpd="sng" algn="ctr">
                       <a:solidFill>
-                        <a:srgbClr val="E3E8F1"/>
+                        <a:srgbClr val="222222"/>
                       </a:solidFill>
                       <a:prstDash val="solid"/>
                       <a:round/>
@@ -4788,7 +4788,7 @@
                     </a:lnL>
                     <a:lnR w="12700" cap="flat" cmpd="sng" algn="ctr">
                       <a:solidFill>
-                        <a:srgbClr val="E3E8F1"/>
+                        <a:srgbClr val="222222"/>
                       </a:solidFill>
                       <a:prstDash val="solid"/>
                       <a:round/>
@@ -4797,7 +4797,7 @@
                     </a:lnR>
                     <a:lnT w="12700" cap="flat" cmpd="sng" algn="ctr">
                       <a:solidFill>
-                        <a:srgbClr val="E3E8F1"/>
+                        <a:srgbClr val="222222"/>
                       </a:solidFill>
                       <a:prstDash val="solid"/>
                       <a:round/>
@@ -4806,7 +4806,7 @@
                     </a:lnT>
                     <a:lnB w="12700" cap="flat" cmpd="sng" algn="ctr">
                       <a:solidFill>
-                        <a:srgbClr val="E3E8F1"/>
+                        <a:srgbClr val="222222"/>
                       </a:solidFill>
                       <a:prstDash val="solid"/>
                       <a:round/>
@@ -4826,7 +4826,7 @@
                       <a:r>
                         <a:rPr lang="en-US" sz="1400" dirty="0">
                           <a:solidFill>
-                            <a:srgbClr val="1B2536"/>
+                            <a:srgbClr val="FFFFFF"/>
                           </a:solidFill>
                         </a:rPr>
                         <a:t>USER + operar el sistema</a:t>
@@ -4837,7 +4837,7 @@
                   <a:tcPr marL="91440" marR="91440" marT="45720" marB="45720">
                     <a:lnL w="12700" cap="flat" cmpd="sng" algn="ctr">
                       <a:solidFill>
-                        <a:srgbClr val="E3E8F1"/>
+                        <a:srgbClr val="222222"/>
                       </a:solidFill>
                       <a:prstDash val="solid"/>
                       <a:round/>
@@ -4846,7 +4846,7 @@
                     </a:lnL>
                     <a:lnR w="12700" cap="flat" cmpd="sng" algn="ctr">
                       <a:solidFill>
-                        <a:srgbClr val="E3E8F1"/>
+                        <a:srgbClr val="222222"/>
                       </a:solidFill>
                       <a:prstDash val="solid"/>
                       <a:round/>
@@ -4855,7 +4855,7 @@
                     </a:lnR>
                     <a:lnT w="12700" cap="flat" cmpd="sng" algn="ctr">
                       <a:solidFill>
-                        <a:srgbClr val="E3E8F1"/>
+                        <a:srgbClr val="222222"/>
                       </a:solidFill>
                       <a:prstDash val="solid"/>
                       <a:round/>
@@ -4864,7 +4864,7 @@
                     </a:lnT>
                     <a:lnB w="12700" cap="flat" cmpd="sng" algn="ctr">
                       <a:solidFill>
-                        <a:srgbClr val="E3E8F1"/>
+                        <a:srgbClr val="222222"/>
                       </a:solidFill>
                       <a:prstDash val="solid"/>
                       <a:round/>
@@ -4905,7 +4905,7 @@
             <a:r>
               <a:rPr lang="en-US" sz="1200" dirty="0">
                 <a:solidFill>
-                  <a:srgbClr val="5B6679"/>
+                  <a:srgbClr val="8A8A8A"/>
                 </a:solidFill>
               </a:rPr>
               <a:t>SUDEV es solo el nombre de producto: internamente sigue siendo SUPERDEV.</a:t>
@@ -4964,7 +4964,7 @@
     <p:bg>
       <p:bgPr>
         <a:solidFill>
-          <a:srgbClr val="FFFFFF"/>
+          <a:srgbClr val="000000"/>
         </a:solidFill>
       </p:bgPr>
     </p:bg>
@@ -5009,7 +5009,7 @@
             <a:r>
               <a:rPr lang="en-US" sz="3000" b="1" dirty="0">
                 <a:solidFill>
-                  <a:srgbClr val="1B2536"/>
+                  <a:srgbClr val="FFFFFF"/>
                 </a:solidFill>
               </a:rPr>
               <a:t>Mi cuenta (RGPD)</a:t>
@@ -5045,7 +5045,7 @@
             <a:r>
               <a:rPr lang="en-US" sz="1600" dirty="0">
                 <a:solidFill>
-                  <a:srgbClr val="5B6679"/>
+                  <a:srgbClr val="8A8A8A"/>
                 </a:solidFill>
               </a:rPr>
               <a:t>Cada persona ve y controla solo lo suyo.</a:t>
@@ -5085,7 +5085,7 @@
             <a:r>
               <a:rPr lang="en-US" sz="1600" dirty="0">
                 <a:solidFill>
-                  <a:srgbClr val="1B2536"/>
+                  <a:srgbClr val="FFFFFF"/>
                 </a:solidFill>
               </a:rPr>
               <a:t>GET /me → perfil + capacidades</a:t>
@@ -5103,7 +5103,7 @@
             <a:r>
               <a:rPr lang="en-US" sz="1600" dirty="0">
                 <a:solidFill>
-                  <a:srgbClr val="1B2536"/>
+                  <a:srgbClr val="FFFFFF"/>
                 </a:solidFill>
               </a:rPr>
               <a:t>GET /me/runs y /me/export → mi historial y mis datos</a:t>
@@ -5121,7 +5121,7 @@
             <a:r>
               <a:rPr lang="en-US" sz="1600" dirty="0">
                 <a:solidFill>
-                  <a:srgbClr val="1B2536"/>
+                  <a:srgbClr val="FFFFFF"/>
                 </a:solidFill>
               </a:rPr>
               <a:t>POST /me/profile → cambiar mi nombre</a:t>
@@ -5139,7 +5139,7 @@
             <a:r>
               <a:rPr lang="en-US" sz="1600" dirty="0">
                 <a:solidFill>
-                  <a:srgbClr val="1B2536"/>
+                  <a:srgbClr val="FFFFFF"/>
                 </a:solidFill>
               </a:rPr>
               <a:t>POST /me/delete → borrar cuenta (pide contraseña; requisito de Apple)</a:t>
@@ -5198,7 +5198,7 @@
     <p:bg>
       <p:bgPr>
         <a:solidFill>
-          <a:srgbClr val="FFFFFF"/>
+          <a:srgbClr val="000000"/>
         </a:solidFill>
       </p:bgPr>
     </p:bg>
@@ -5243,7 +5243,7 @@
             <a:r>
               <a:rPr lang="en-US" sz="3000" b="1" dirty="0">
                 <a:solidFill>
-                  <a:srgbClr val="1B2536"/>
+                  <a:srgbClr val="FFFFFF"/>
                 </a:solidFill>
               </a:rPr>
               <a:t>Operación sudev</a:t>
@@ -5279,7 +5279,7 @@
             <a:r>
               <a:rPr lang="en-US" sz="1600" dirty="0">
                 <a:solidFill>
-                  <a:srgbClr val="5B6679"/>
+                  <a:srgbClr val="8A8A8A"/>
                 </a:solidFill>
               </a:rPr>
               <a:t>Solo el rol más alto, y siempre por debajo de sí mismo.</a:t>
@@ -5319,7 +5319,7 @@
             <a:r>
               <a:rPr lang="en-US" sz="1600" dirty="0">
                 <a:solidFill>
-                  <a:srgbClr val="1B2536"/>
+                  <a:srgbClr val="FFFFFF"/>
                 </a:solidFill>
               </a:rPr>
               <a:t>Listar perfiles con número de recorridos</a:t>
@@ -5337,7 +5337,7 @@
             <a:r>
               <a:rPr lang="en-US" sz="1600" dirty="0">
                 <a:solidFill>
-                  <a:srgbClr val="1B2536"/>
+                  <a:srgbClr val="FFFFFF"/>
                 </a:solidFill>
               </a:rPr>
               <a:t>Asignar rol, con motivo y auditoría en la misma transacción</a:t>
@@ -5355,7 +5355,7 @@
             <a:r>
               <a:rPr lang="en-US" sz="1600" dirty="0">
                 <a:solidFill>
-                  <a:srgbClr val="1B2536"/>
+                  <a:srgbClr val="FFFFFF"/>
                 </a:solidFill>
               </a:rPr>
               <a:t>Desactivar o reactivar cuentas</a:t>
@@ -5373,7 +5373,7 @@
             <a:r>
               <a:rPr lang="en-US" sz="1600" dirty="0">
                 <a:solidFill>
-                  <a:srgbClr val="1B2536"/>
+                  <a:srgbClr val="FFFFFF"/>
                 </a:solidFill>
               </a:rPr>
               <a:t>Nadie se cambia a sí mismo, toca a un igual ni sube a otro a su nivel</a:t>
@@ -5432,7 +5432,7 @@
     <p:bg>
       <p:bgPr>
         <a:solidFill>
-          <a:srgbClr val="FFFFFF"/>
+          <a:srgbClr val="000000"/>
         </a:solidFill>
       </p:bgPr>
     </p:bg>
@@ -5477,7 +5477,7 @@
             <a:r>
               <a:rPr lang="en-US" sz="3000" b="1" dirty="0">
                 <a:solidFill>
-                  <a:srgbClr val="1B2536"/>
+                  <a:srgbClr val="FFFFFF"/>
                 </a:solidFill>
               </a:rPr>
               <a:t>El historial se guarda</a:t>
@@ -5513,7 +5513,7 @@
             <a:r>
               <a:rPr lang="en-US" sz="1600" dirty="0">
                 <a:solidFill>
-                  <a:srgbClr val="5B6679"/>
+                  <a:srgbClr val="8A8A8A"/>
                 </a:solidFill>
               </a:rPr>
               <a:t>Al terminar las 3 fases, la API guarda el recorrido.</a:t>
@@ -5553,7 +5553,7 @@
             <a:r>
               <a:rPr lang="en-US" sz="1600" dirty="0">
                 <a:solidFill>
-                  <a:srgbClr val="1B2536"/>
+                  <a:srgbClr val="FFFFFF"/>
                 </a:solidFill>
               </a:rPr>
               <a:t>Solo lo que devuelve el motor: 3 mediciones (fase, fila, columna)</a:t>
@@ -5571,7 +5571,7 @@
             <a:r>
               <a:rPr lang="en-US" sz="1600" dirty="0">
                 <a:solidFill>
-                  <a:srgbClr val="1B2536"/>
+                  <a:srgbClr val="FFFFFF"/>
                 </a:solidFill>
               </a:rPr>
               <a:t>Si guardar falla, la respuesta a la persona no se rompe</a:t>
@@ -5589,7 +5589,7 @@
             <a:r>
               <a:rPr lang="en-US" sz="1600" dirty="0">
                 <a:solidFill>
-                  <a:srgbClr val="1B2536"/>
+                  <a:srgbClr val="FFFFFF"/>
                 </a:solidFill>
               </a:rPr>
               <a:t>Reintentos no duplican</a:t>
@@ -5607,7 +5607,7 @@
             <a:r>
               <a:rPr lang="en-US" sz="1600" dirty="0">
                 <a:solidFill>
-                  <a:srgbClr val="1B2536"/>
+                  <a:srgbClr val="FFFFFF"/>
                 </a:solidFill>
               </a:rPr>
               <a:t>TypeScript no calcula nada del Cubo</a:t>
@@ -5666,7 +5666,7 @@
     <p:bg>
       <p:bgPr>
         <a:solidFill>
-          <a:srgbClr val="FFFFFF"/>
+          <a:srgbClr val="000000"/>
         </a:solidFill>
       </p:bgPr>
     </p:bg>
@@ -5711,7 +5711,7 @@
             <a:r>
               <a:rPr lang="en-US" sz="3000" b="1" dirty="0">
                 <a:solidFill>
-                  <a:srgbClr val="1B2536"/>
+                  <a:srgbClr val="FFFFFF"/>
                 </a:solidFill>
               </a:rPr>
               <a:t>Base de datos Neon</a:t>
@@ -5747,7 +5747,7 @@
             <a:r>
               <a:rPr lang="en-US" sz="1600" dirty="0">
                 <a:solidFill>
-                  <a:srgbClr val="5B6679"/>
+                  <a:srgbClr val="8A8A8A"/>
                 </a:solidFill>
               </a:rPr>
               <a:t>Verificada contra la base real.</a:t>
@@ -5773,11 +5773,11 @@
             </a:avLst>
           </a:prstGeom>
           <a:solidFill>
-            <a:srgbClr val="F1F5FB"/>
+            <a:srgbClr val="0A0A0A"/>
           </a:solidFill>
           <a:ln w="12700">
             <a:solidFill>
-              <a:srgbClr val="F1F5FB"/>
+              <a:srgbClr val="222222"/>
             </a:solidFill>
             <a:prstDash val="solid"/>
           </a:ln>
@@ -5810,7 +5810,7 @@
             <a:r>
               <a:rPr lang="en-US" sz="3600" b="1" dirty="0">
                 <a:solidFill>
-                  <a:srgbClr val="2F6FED"/>
+                  <a:srgbClr val="39FF14"/>
                 </a:solidFill>
               </a:rPr>
               <a:t>1</a:t>
@@ -5846,7 +5846,7 @@
             <a:r>
               <a:rPr lang="en-US" sz="1200" dirty="0">
                 <a:solidFill>
-                  <a:srgbClr val="5B6679"/>
+                  <a:srgbClr val="8A8A8A"/>
                 </a:solidFill>
               </a:rPr>
               <a:t>migración aplicada</a:t>
@@ -5872,11 +5872,11 @@
             </a:avLst>
           </a:prstGeom>
           <a:solidFill>
-            <a:srgbClr val="F1F5FB"/>
+            <a:srgbClr val="0A0A0A"/>
           </a:solidFill>
           <a:ln w="12700">
             <a:solidFill>
-              <a:srgbClr val="F1F5FB"/>
+              <a:srgbClr val="222222"/>
             </a:solidFill>
             <a:prstDash val="solid"/>
           </a:ln>
@@ -5909,7 +5909,7 @@
             <a:r>
               <a:rPr lang="en-US" sz="3600" b="1" dirty="0">
                 <a:solidFill>
-                  <a:srgbClr val="2F6FED"/>
+                  <a:srgbClr val="39FF14"/>
                 </a:solidFill>
               </a:rPr>
               <a:t>13</a:t>
@@ -5945,7 +5945,7 @@
             <a:r>
               <a:rPr lang="en-US" sz="1200" dirty="0">
                 <a:solidFill>
-                  <a:srgbClr val="5B6679"/>
+                  <a:srgbClr val="8A8A8A"/>
                 </a:solidFill>
               </a:rPr>
               <a:t>capacidades sembradas</a:t>
@@ -5971,11 +5971,11 @@
             </a:avLst>
           </a:prstGeom>
           <a:solidFill>
-            <a:srgbClr val="F1F5FB"/>
+            <a:srgbClr val="0A0A0A"/>
           </a:solidFill>
           <a:ln w="12700">
             <a:solidFill>
-              <a:srgbClr val="F1F5FB"/>
+              <a:srgbClr val="222222"/>
             </a:solidFill>
             <a:prstDash val="solid"/>
           </a:ln>
@@ -6008,7 +6008,7 @@
             <a:r>
               <a:rPr lang="en-US" sz="3600" b="1" dirty="0">
                 <a:solidFill>
-                  <a:srgbClr val="2F6FED"/>
+                  <a:srgbClr val="39FF14"/>
                 </a:solidFill>
               </a:rPr>
               <a:t>2</a:t>
@@ -6044,7 +6044,7 @@
             <a:r>
               <a:rPr lang="en-US" sz="1200" dirty="0">
                 <a:solidFill>
-                  <a:srgbClr val="5B6679"/>
+                  <a:srgbClr val="8A8A8A"/>
                 </a:solidFill>
               </a:rPr>
               <a:t>tests contra Neon real</a:t>
@@ -6084,7 +6084,7 @@
             <a:r>
               <a:rPr lang="en-US" sz="1600" dirty="0">
                 <a:solidFill>
-                  <a:srgbClr val="1B2536"/>
+                  <a:srgbClr val="FFFFFF"/>
                 </a:solidFill>
               </a:rPr>
               <a:t>Auditoría de roles solo-anexar (no se puede borrar ni editar)</a:t>
@@ -6102,7 +6102,7 @@
             <a:r>
               <a:rPr lang="en-US" sz="1600" dirty="0">
                 <a:solidFill>
-                  <a:srgbClr val="1B2536"/>
+                  <a:srgbClr val="FFFFFF"/>
                 </a:solidFill>
               </a:rPr>
               <a:t>Sin memoria: si Neon falla, se ve el fallo</a:t>
@@ -6161,7 +6161,7 @@
     <p:bg>
       <p:bgPr>
         <a:solidFill>
-          <a:srgbClr val="FFFFFF"/>
+          <a:srgbClr val="000000"/>
         </a:solidFill>
       </p:bgPr>
     </p:bg>
@@ -6206,7 +6206,7 @@
             <a:r>
               <a:rPr lang="en-US" sz="3000" b="1" dirty="0">
                 <a:solidFill>
-                  <a:srgbClr val="1B2536"/>
+                  <a:srgbClr val="FFFFFF"/>
                 </a:solidFill>
               </a:rPr>
               <a:t>Motor C++ · neos-cube</a:t>
@@ -6242,7 +6242,7 @@
             <a:r>
               <a:rPr lang="en-US" sz="1600" dirty="0">
                 <a:solidFill>
-                  <a:srgbClr val="5B6679"/>
+                  <a:srgbClr val="8A8A8A"/>
                 </a:solidFill>
               </a:rPr>
               <a:t>Público, determinista y portable (Windows, macOS, Linux).</a:t>
@@ -6282,7 +6282,7 @@
             <a:r>
               <a:rPr lang="en-US" sz="1600" dirty="0">
                 <a:solidFill>
-                  <a:srgbClr val="1B2536"/>
+                  <a:srgbClr val="FFFFFF"/>
                 </a:solidFill>
               </a:rPr>
               <a:t>Servicio local autenticado en 127.0.0.1:8765</a:t>
@@ -6300,7 +6300,7 @@
             <a:r>
               <a:rPr lang="en-US" sz="1600" dirty="0">
                 <a:solidFill>
-                  <a:srgbClr val="1B2536"/>
+                  <a:srgbClr val="FFFFFF"/>
                 </a:solidFill>
               </a:rPr>
               <a:t>Tests del núcleo y prueba de humo extremo a extremo</a:t>
@@ -6318,7 +6318,7 @@
             <a:r>
               <a:rPr lang="en-US" sz="1600" dirty="0">
                 <a:solidFill>
-                  <a:srgbClr val="1B2536"/>
+                  <a:srgbClr val="FFFFFF"/>
                 </a:solidFill>
               </a:rPr>
               <a:t>Ejemplo simulate_runs: 600 recorridos sintéticos con la librería real</a:t>
@@ -6336,7 +6336,7 @@
             <a:r>
               <a:rPr lang="en-US" sz="1600" dirty="0">
                 <a:solidFill>
-                  <a:srgbClr val="1B2536"/>
+                  <a:srgbClr val="FFFFFF"/>
                 </a:solidFill>
               </a:rPr>
               <a:t>Sin inferencia: espera una especificación matemática aprobada</a:t>

</xml_diff>